<commit_message>
Teach the shared cloud VPC picture in Lecture 3 so Lecture 4 can stay console clicks.
Co-authored-by: Cursor <cursoragent@cursor.com>
</commit_message>
<xml_diff>
--- a/lec-04/presentation/lec-04-aws-fundamentals.pptx
+++ b/lec-04/presentation/lec-04-aws-fundamentals.pptx
@@ -126,14 +126,14 @@
   <p:extLst>
     <p:ext uri="{521415D9-36F7-43E2-AB2F-B90AF26B5E84}">
       <p14:sectionLst xmlns:p14="http://schemas.microsoft.com/office/powerpoint/2010/main">
-        <p14:section name="Welcome" id="{3679cccf-82f5-a0c4-4030-58dce46ad64a}">
+        <p14:section name="Welcome" id="{4a6a67ad-0bbd-d496-6d9d-c33d1b2a7d8b}">
           <p14:sldIdLst>
             <p14:sldId id="256"/>
             <p14:sldId id="257"/>
             <p14:sldId id="258"/>
           </p14:sldIdLst>
         </p14:section>
-        <p14:section name="Account" id="{d6884f57-f5e8-bc5c-d962-466d054810b0}">
+        <p14:section name="Account" id="{54672c9f-2944-8a39-6c63-354cf0e11eb5}">
           <p14:sldIdLst>
             <p14:sldId id="259"/>
             <p14:sldId id="260"/>
@@ -141,7 +141,7 @@
             <p14:sldId id="262"/>
           </p14:sldIdLst>
         </p14:section>
-        <p14:section name="The tiny stack" id="{e38b9c8f-12ca-23b1-34a0-13732c84288a}">
+        <p14:section name="The tiny stack" id="{7ced4520-2704-adda-f2c9-b96bc337dc1d}">
           <p14:sldIdLst>
             <p14:sldId id="263"/>
             <p14:sldId id="264"/>
@@ -152,13 +152,13 @@
             <p14:sldId id="269"/>
           </p14:sldIdLst>
         </p14:section>
-        <p14:section name="Lab" id="{93fc13e1-7867-ca25-4855-17b2e8254801}">
+        <p14:section name="Lab" id="{7970b523-4d87-4faf-7a90-ca758eb176c7}">
           <p14:sldIdLst>
             <p14:sldId id="270"/>
             <p14:sldId id="271"/>
           </p14:sldIdLst>
         </p14:section>
-        <p14:section name="Interview and close" id="{30830ec0-1a6a-e024-1327-ada9525cf5f9}">
+        <p14:section name="Interview and close" id="{ae7ca9c3-579a-3568-6d9c-add74573c187}">
           <p14:sldIdLst>
             <p14:sldId id="272"/>
             <p14:sldId id="273"/>
@@ -12853,7 +12853,7 @@
                   <a:srgbClr val="94A3B8"/>
                 </a:solidFill>
               </a:rPr>
-              <a:t>Internet → IGW → public subnet → one micro + security group.</a:t>
+              <a:t>You drew this in lecture 3. Today we click it on AWS.</a:t>
             </a:r>
             <a:endParaRPr lang="en-US" sz="1800" dirty="0"/>
           </a:p>

</xml_diff>